<commit_message>
regen references - remove shapes
</commit_message>
<xml_diff>
--- a/report-generator/tests/report_generator/integration/reference_modernization.pptx
+++ b/report-generator/tests/report_generator/integration/reference_modernization.pptx
@@ -257,7 +257,7 @@
                 </a:outerShdw>
               </a:effectLst>
             </c:spPr>
-            <c:extLst xmlns:lc="http://schemas.openxmlformats.org/drawingml/2006/lockedCanvas" xmlns:comp="http://schemas.openxmlformats.org/drawingml/2006/compatibility" xmlns:we="http://schemas.microsoft.com/office/webextensions/webextension/2010/11" xmlns:wetp="http://schemas.microsoft.com/office/webextensions/taskpanes/2010/11" xmlns:w16cid="http://schemas.microsoft.com/office/word/2016/wordml/cid" xmlns:w16se="http://schemas.microsoft.com/office/word/2015/wordml/symex" xmlns:wps="http://schemas.microsoft.com/office/word/2010/wordprocessingShape" xmlns:b="http://schemas.openxmlformats.org/officeDocument/2006/bibliography" xmlns:odgm="http://opendope.org/SmartArt/DataHierarchy" xmlns:odi="http://opendope.org/components" xmlns:oda="http://opendope.org/answers" xmlns:odq="http://opendope.org/questions" xmlns:odc="http://opendope.org/conditions" xmlns:odx="http://opendope.org/xpaths" xmlns:cppr="http://schemas.microsoft.com/office/2006/coverPageProps" xmlns:pvml="urn:schemas-microsoft-com:office:powerpoint" xmlns:w10="urn:schemas-microsoft-com:office:word" xmlns:v="urn:schemas-microsoft-com:vml" xmlns:o="urn:schemas-microsoft-com:office:office" xmlns:xvml="urn:schemas-microsoft-com:office:excel" xmlns:dsp="http://schemas.microsoft.com/office/drawing/2008/diagram" xmlns:xdr="http://schemas.openxmlformats.org/drawingml/2006/spreadsheetDrawing" xmlns:pic="http://schemas.openxmlformats.org/drawingml/2006/picture" xmlns:dgm="http://schemas.openxmlformats.org/drawingml/2006/diagram" xmlns:c14="http://schemas.microsoft.com/office/drawing/2007/8/2/chart" xmlns:cdr="http://schemas.openxmlformats.org/drawingml/2006/chartDrawing" xmlns:wne="http://schemas.microsoft.com/office/word/2006/wordml" xmlns:sl="http://schemas.openxmlformats.org/schemaLibrary/2006/main" xmlns:mc="http://schemas.openxmlformats.org/markup-compatibility/2006" xmlns:wp14="http://schemas.microsoft.com/office/word/2010/wordprocessingDrawing" xmlns:wp="http://schemas.openxmlformats.org/drawingml/2006/wordprocessingDrawing" xmlns:m="http://schemas.openxmlformats.org/officeDocument/2006/math" xmlns:w14="http://schemas.microsoft.com/office/word/2010/wordml" xmlns:w15="http://schemas.microsoft.com/office/word/2012/wordml" xmlns:w="http://schemas.openxmlformats.org/wordprocessingml/2006/main">
+            <c:extLst xmlns:w="http://schemas.openxmlformats.org/wordprocessingml/2006/main" xmlns:w15="http://schemas.microsoft.com/office/word/2012/wordml" xmlns:w14="http://schemas.microsoft.com/office/word/2010/wordml" xmlns:m="http://schemas.openxmlformats.org/officeDocument/2006/math" xmlns:wp="http://schemas.openxmlformats.org/drawingml/2006/wordprocessingDrawing" xmlns:wp14="http://schemas.microsoft.com/office/word/2010/wordprocessingDrawing" xmlns:mc="http://schemas.openxmlformats.org/markup-compatibility/2006" xmlns:sl="http://schemas.openxmlformats.org/schemaLibrary/2006/main" xmlns:wne="http://schemas.microsoft.com/office/word/2006/wordml" xmlns:cdr="http://schemas.openxmlformats.org/drawingml/2006/chartDrawing" xmlns:c14="http://schemas.microsoft.com/office/drawing/2007/8/2/chart" xmlns:dgm="http://schemas.openxmlformats.org/drawingml/2006/diagram" xmlns:pic="http://schemas.openxmlformats.org/drawingml/2006/picture" xmlns:xdr="http://schemas.openxmlformats.org/drawingml/2006/spreadsheetDrawing" xmlns:dsp="http://schemas.microsoft.com/office/drawing/2008/diagram" xmlns:xvml="urn:schemas-microsoft-com:office:excel" xmlns:o="urn:schemas-microsoft-com:office:office" xmlns:v="urn:schemas-microsoft-com:vml" xmlns:w10="urn:schemas-microsoft-com:office:word" xmlns:pvml="urn:schemas-microsoft-com:office:powerpoint" xmlns:cppr="http://schemas.microsoft.com/office/2006/coverPageProps" xmlns:odx="http://opendope.org/xpaths" xmlns:odc="http://opendope.org/conditions" xmlns:odq="http://opendope.org/questions" xmlns:oda="http://opendope.org/answers" xmlns:odi="http://opendope.org/components" xmlns:odgm="http://opendope.org/SmartArt/DataHierarchy" xmlns:b="http://schemas.openxmlformats.org/officeDocument/2006/bibliography" xmlns:wps="http://schemas.microsoft.com/office/word/2010/wordprocessingShape" xmlns:w16se="http://schemas.microsoft.com/office/word/2015/wordml/symex" xmlns:w16cid="http://schemas.microsoft.com/office/word/2016/wordml/cid" xmlns:wetp="http://schemas.microsoft.com/office/webextensions/taskpanes/2010/11" xmlns:we="http://schemas.microsoft.com/office/webextensions/webextension/2010/11" xmlns:comp="http://schemas.openxmlformats.org/drawingml/2006/compatibility" xmlns:lc="http://schemas.openxmlformats.org/drawingml/2006/lockedCanvas">
               <c:ext xmlns:c16="http://schemas.microsoft.com/office/drawing/2014/chart" uri="{C3380CC4-5D6E-409C-BE32-E72D297353CC}">
                 <c16:uniqueId val="{00000001-8D46-3D4B-996A-4B880DC4E095}"/>
               </c:ext>
@@ -353,37 +353,37 @@
                   <c:v>118.73782</c:v>
                 </c:pt>
                 <c:pt idx="5">
-                  <c:v>90.58979</c:v>
+                  <c:v>90.589789999999994</c:v>
                 </c:pt>
                 <c:pt idx="6">
-                  <c:v>79.72585</c:v>
+                  <c:v>79.725849999999994</c:v>
                 </c:pt>
                 <c:pt idx="7">
-                  <c:v>70.96459334320562</c:v>
+                  <c:v>70.964593343205621</c:v>
                 </c:pt>
                 <c:pt idx="8">
-                  <c:v>69.70323</c:v>
+                  <c:v>69.703230000000005</c:v>
                 </c:pt>
                 <c:pt idx="9">
                   <c:v>56.01164</c:v>
                 </c:pt>
                 <c:pt idx="10">
-                  <c:v>39.71483466072114</c:v>
+                  <c:v>39.714834660721138</c:v>
                 </c:pt>
                 <c:pt idx="11">
-                  <c:v>34.84491</c:v>
+                  <c:v>34.844909999999999</c:v>
                 </c:pt>
                 <c:pt idx="12">
-                  <c:v>34.27488</c:v>
+                  <c:v>34.274880000000003</c:v>
                 </c:pt>
                 <c:pt idx="13">
-                  <c:v>33.21055</c:v>
+                  <c:v>33.210549999999998</c:v>
                 </c:pt>
                 <c:pt idx="14">
-                  <c:v>31.26918</c:v>
+                  <c:v>31.269179999999999</c:v>
                 </c:pt>
                 <c:pt idx="15">
-                  <c:v>30.57731</c:v>
+                  <c:v>30.577310000000001</c:v>
                 </c:pt>
                 <c:pt idx="16">
                   <c:v>28.55415</c:v>
@@ -392,15 +392,15 @@
                   <c:v>24.45168</c:v>
                 </c:pt>
                 <c:pt idx="18">
-                  <c:v>23.16484341436872</c:v>
+                  <c:v>23.164843414368718</c:v>
                 </c:pt>
                 <c:pt idx="19">
-                  <c:v>18.8132</c:v>
+                  <c:v>18.813199999999998</c:v>
                 </c:pt>
               </c:numCache>
             </c:numRef>
           </c:val>
-          <c:extLst xmlns:lc="http://schemas.openxmlformats.org/drawingml/2006/lockedCanvas" xmlns:comp="http://schemas.openxmlformats.org/drawingml/2006/compatibility" xmlns:we="http://schemas.microsoft.com/office/webextensions/webextension/2010/11" xmlns:wetp="http://schemas.microsoft.com/office/webextensions/taskpanes/2010/11" xmlns:w16cid="http://schemas.microsoft.com/office/word/2016/wordml/cid" xmlns:w16se="http://schemas.microsoft.com/office/word/2015/wordml/symex" xmlns:wps="http://schemas.microsoft.com/office/word/2010/wordprocessingShape" xmlns:b="http://schemas.openxmlformats.org/officeDocument/2006/bibliography" xmlns:odgm="http://opendope.org/SmartArt/DataHierarchy" xmlns:odi="http://opendope.org/components" xmlns:oda="http://opendope.org/answers" xmlns:odq="http://opendope.org/questions" xmlns:odc="http://opendope.org/conditions" xmlns:odx="http://opendope.org/xpaths" xmlns:cppr="http://schemas.microsoft.com/office/2006/coverPageProps" xmlns:pvml="urn:schemas-microsoft-com:office:powerpoint" xmlns:w10="urn:schemas-microsoft-com:office:word" xmlns:v="urn:schemas-microsoft-com:vml" xmlns:o="urn:schemas-microsoft-com:office:office" xmlns:xvml="urn:schemas-microsoft-com:office:excel" xmlns:dsp="http://schemas.microsoft.com/office/drawing/2008/diagram" xmlns:xdr="http://schemas.openxmlformats.org/drawingml/2006/spreadsheetDrawing" xmlns:pic="http://schemas.openxmlformats.org/drawingml/2006/picture" xmlns:dgm="http://schemas.openxmlformats.org/drawingml/2006/diagram" xmlns:c14="http://schemas.microsoft.com/office/drawing/2007/8/2/chart" xmlns:cdr="http://schemas.openxmlformats.org/drawingml/2006/chartDrawing" xmlns:wne="http://schemas.microsoft.com/office/word/2006/wordml" xmlns:sl="http://schemas.openxmlformats.org/schemaLibrary/2006/main" xmlns:mc="http://schemas.openxmlformats.org/markup-compatibility/2006" xmlns:wp14="http://schemas.microsoft.com/office/word/2010/wordprocessingDrawing" xmlns:wp="http://schemas.openxmlformats.org/drawingml/2006/wordprocessingDrawing" xmlns:m="http://schemas.openxmlformats.org/officeDocument/2006/math" xmlns:w14="http://schemas.microsoft.com/office/word/2010/wordml" xmlns:w15="http://schemas.microsoft.com/office/word/2012/wordml" xmlns:w="http://schemas.openxmlformats.org/wordprocessingml/2006/main">
+          <c:extLst xmlns:w="http://schemas.openxmlformats.org/wordprocessingml/2006/main" xmlns:w15="http://schemas.microsoft.com/office/word/2012/wordml" xmlns:w14="http://schemas.microsoft.com/office/word/2010/wordml" xmlns:m="http://schemas.openxmlformats.org/officeDocument/2006/math" xmlns:wp="http://schemas.openxmlformats.org/drawingml/2006/wordprocessingDrawing" xmlns:wp14="http://schemas.microsoft.com/office/word/2010/wordprocessingDrawing" xmlns:mc="http://schemas.openxmlformats.org/markup-compatibility/2006" xmlns:sl="http://schemas.openxmlformats.org/schemaLibrary/2006/main" xmlns:wne="http://schemas.microsoft.com/office/word/2006/wordml" xmlns:cdr="http://schemas.openxmlformats.org/drawingml/2006/chartDrawing" xmlns:c14="http://schemas.microsoft.com/office/drawing/2007/8/2/chart" xmlns:dgm="http://schemas.openxmlformats.org/drawingml/2006/diagram" xmlns:pic="http://schemas.openxmlformats.org/drawingml/2006/picture" xmlns:xdr="http://schemas.openxmlformats.org/drawingml/2006/spreadsheetDrawing" xmlns:dsp="http://schemas.microsoft.com/office/drawing/2008/diagram" xmlns:xvml="urn:schemas-microsoft-com:office:excel" xmlns:o="urn:schemas-microsoft-com:office:office" xmlns:v="urn:schemas-microsoft-com:vml" xmlns:w10="urn:schemas-microsoft-com:office:word" xmlns:pvml="urn:schemas-microsoft-com:office:powerpoint" xmlns:cppr="http://schemas.microsoft.com/office/2006/coverPageProps" xmlns:odx="http://opendope.org/xpaths" xmlns:odc="http://opendope.org/conditions" xmlns:odq="http://opendope.org/questions" xmlns:oda="http://opendope.org/answers" xmlns:odi="http://opendope.org/components" xmlns:odgm="http://opendope.org/SmartArt/DataHierarchy" xmlns:b="http://schemas.openxmlformats.org/officeDocument/2006/bibliography" xmlns:wps="http://schemas.microsoft.com/office/word/2010/wordprocessingShape" xmlns:w16se="http://schemas.microsoft.com/office/word/2015/wordml/symex" xmlns:w16cid="http://schemas.microsoft.com/office/word/2016/wordml/cid" xmlns:wetp="http://schemas.microsoft.com/office/webextensions/taskpanes/2010/11" xmlns:we="http://schemas.microsoft.com/office/webextensions/webextension/2010/11" xmlns:comp="http://schemas.openxmlformats.org/drawingml/2006/compatibility" xmlns:lc="http://schemas.openxmlformats.org/drawingml/2006/lockedCanvas">
             <c:ext xmlns:c16="http://schemas.microsoft.com/office/drawing/2014/chart" uri="{C3380CC4-5D6E-409C-BE32-E72D297353CC}">
               <c16:uniqueId val="{00000004-8D46-3D4B-996A-4B880DC4E095}"/>
             </c:ext>
@@ -505,13 +505,13 @@
                 <c:formatCode>General</c:formatCode>
                 <c:ptCount val="20"/>
                 <c:pt idx="0">
-                  <c:v>0.0</c:v>
+                  <c:v>0</c:v>
                 </c:pt>
                 <c:pt idx="1">
                   <c:v>163.50925951217985</c:v>
                 </c:pt>
                 <c:pt idx="2">
-                  <c:v>0.0</c:v>
+                  <c:v>0</c:v>
                 </c:pt>
                 <c:pt idx="3">
                   <c:v>125.69901258506576</c:v>
@@ -523,10 +523,10 @@
                   <c:v>10.386528597698714</c:v>
                 </c:pt>
                 <c:pt idx="6">
-                  <c:v>79.46538441612817</c:v>
+                  <c:v>79.465384416128174</c:v>
                 </c:pt>
                 <c:pt idx="7">
-                  <c:v>0.0</c:v>
+                  <c:v>0</c:v>
                 </c:pt>
                 <c:pt idx="8">
                   <c:v>11.918359176828517</c:v>
@@ -535,7 +535,7 @@
                   <c:v>79.59140060338413</c:v>
                 </c:pt>
                 <c:pt idx="10">
-                  <c:v>0.0</c:v>
+                  <c:v>0</c:v>
                 </c:pt>
                 <c:pt idx="11">
                   <c:v>10.294089999999962</c:v>
@@ -544,25 +544,25 @@
                   <c:v>21.230302824691023</c:v>
                 </c:pt>
                 <c:pt idx="13">
-                  <c:v>48.0289397609055</c:v>
+                  <c:v>48.028939760905502</c:v>
                 </c:pt>
                 <c:pt idx="14">
-                  <c:v>45.29529245170047</c:v>
+                  <c:v>45.295292451700469</c:v>
                 </c:pt>
                 <c:pt idx="15">
                   <c:v>42.2820233333332</c:v>
                 </c:pt>
                 <c:pt idx="16">
-                  <c:v>88.37801991312301</c:v>
+                  <c:v>88.378019913123012</c:v>
                 </c:pt>
                 <c:pt idx="17">
                   <c:v>12.3791647252819</c:v>
                 </c:pt>
                 <c:pt idx="18">
-                  <c:v>0.0</c:v>
+                  <c:v>0</c:v>
                 </c:pt>
                 <c:pt idx="19">
-                  <c:v>58.51978297129445</c:v>
+                  <c:v>58.519782971294447</c:v>
                 </c:pt>
               </c:numCache>
             </c:numRef>
@@ -700,7 +700,7 @@
     <c:plotVisOnly val="1"/>
     <c:dispBlanksAs val="gap"/>
     <c:showDLblsOverMax val="0"/>
-    <c:extLst xmlns:lc="http://schemas.openxmlformats.org/drawingml/2006/lockedCanvas" xmlns:comp="http://schemas.openxmlformats.org/drawingml/2006/compatibility" xmlns:we="http://schemas.microsoft.com/office/webextensions/webextension/2010/11" xmlns:wetp="http://schemas.microsoft.com/office/webextensions/taskpanes/2010/11" xmlns:w16cid="http://schemas.microsoft.com/office/word/2016/wordml/cid" xmlns:w16se="http://schemas.microsoft.com/office/word/2015/wordml/symex" xmlns:wps="http://schemas.microsoft.com/office/word/2010/wordprocessingShape" xmlns:b="http://schemas.openxmlformats.org/officeDocument/2006/bibliography" xmlns:odgm="http://opendope.org/SmartArt/DataHierarchy" xmlns:odi="http://opendope.org/components" xmlns:oda="http://opendope.org/answers" xmlns:odq="http://opendope.org/questions" xmlns:odc="http://opendope.org/conditions" xmlns:odx="http://opendope.org/xpaths" xmlns:cppr="http://schemas.microsoft.com/office/2006/coverPageProps" xmlns:pvml="urn:schemas-microsoft-com:office:powerpoint" xmlns:w10="urn:schemas-microsoft-com:office:word" xmlns:v="urn:schemas-microsoft-com:vml" xmlns:o="urn:schemas-microsoft-com:office:office" xmlns:xvml="urn:schemas-microsoft-com:office:excel" xmlns:dsp="http://schemas.microsoft.com/office/drawing/2008/diagram" xmlns:xdr="http://schemas.openxmlformats.org/drawingml/2006/spreadsheetDrawing" xmlns:pic="http://schemas.openxmlformats.org/drawingml/2006/picture" xmlns:dgm="http://schemas.openxmlformats.org/drawingml/2006/diagram" xmlns:c14="http://schemas.microsoft.com/office/drawing/2007/8/2/chart" xmlns:cdr="http://schemas.openxmlformats.org/drawingml/2006/chartDrawing" xmlns:wne="http://schemas.microsoft.com/office/word/2006/wordml" xmlns:sl="http://schemas.openxmlformats.org/schemaLibrary/2006/main" xmlns:mc="http://schemas.openxmlformats.org/markup-compatibility/2006" xmlns:wp14="http://schemas.microsoft.com/office/word/2010/wordprocessingDrawing" xmlns:wp="http://schemas.openxmlformats.org/drawingml/2006/wordprocessingDrawing" xmlns:m="http://schemas.openxmlformats.org/officeDocument/2006/math" xmlns:w14="http://schemas.microsoft.com/office/word/2010/wordml" xmlns:w15="http://schemas.microsoft.com/office/word/2012/wordml" xmlns:w="http://schemas.openxmlformats.org/wordprocessingml/2006/main">
+    <c:extLst xmlns:w="http://schemas.openxmlformats.org/wordprocessingml/2006/main" xmlns:w15="http://schemas.microsoft.com/office/word/2012/wordml" xmlns:w14="http://schemas.microsoft.com/office/word/2010/wordml" xmlns:m="http://schemas.openxmlformats.org/officeDocument/2006/math" xmlns:wp="http://schemas.openxmlformats.org/drawingml/2006/wordprocessingDrawing" xmlns:wp14="http://schemas.microsoft.com/office/word/2010/wordprocessingDrawing" xmlns:mc="http://schemas.openxmlformats.org/markup-compatibility/2006" xmlns:sl="http://schemas.openxmlformats.org/schemaLibrary/2006/main" xmlns:wne="http://schemas.microsoft.com/office/word/2006/wordml" xmlns:cdr="http://schemas.openxmlformats.org/drawingml/2006/chartDrawing" xmlns:c14="http://schemas.microsoft.com/office/drawing/2007/8/2/chart" xmlns:dgm="http://schemas.openxmlformats.org/drawingml/2006/diagram" xmlns:pic="http://schemas.openxmlformats.org/drawingml/2006/picture" xmlns:xdr="http://schemas.openxmlformats.org/drawingml/2006/spreadsheetDrawing" xmlns:dsp="http://schemas.microsoft.com/office/drawing/2008/diagram" xmlns:xvml="urn:schemas-microsoft-com:office:excel" xmlns:o="urn:schemas-microsoft-com:office:office" xmlns:v="urn:schemas-microsoft-com:vml" xmlns:w10="urn:schemas-microsoft-com:office:word" xmlns:pvml="urn:schemas-microsoft-com:office:powerpoint" xmlns:cppr="http://schemas.microsoft.com/office/2006/coverPageProps" xmlns:odx="http://opendope.org/xpaths" xmlns:odc="http://opendope.org/conditions" xmlns:odq="http://opendope.org/questions" xmlns:oda="http://opendope.org/answers" xmlns:odi="http://opendope.org/components" xmlns:odgm="http://opendope.org/SmartArt/DataHierarchy" xmlns:b="http://schemas.openxmlformats.org/officeDocument/2006/bibliography" xmlns:wps="http://schemas.microsoft.com/office/word/2010/wordprocessingShape" xmlns:w16se="http://schemas.microsoft.com/office/word/2015/wordml/symex" xmlns:w16cid="http://schemas.microsoft.com/office/word/2016/wordml/cid" xmlns:wetp="http://schemas.microsoft.com/office/webextensions/taskpanes/2010/11" xmlns:we="http://schemas.microsoft.com/office/webextensions/webextension/2010/11" xmlns:comp="http://schemas.openxmlformats.org/drawingml/2006/compatibility" xmlns:lc="http://schemas.openxmlformats.org/drawingml/2006/lockedCanvas">
       <c:ext xmlns:c16r3="http://schemas.microsoft.com/office/drawing/2017/03/chart" uri="{56B9EC1D-385E-4148-901F-78D8002777C0}">
         <c16r3:dataDisplayOptions16>
           <c16r3:dispNaAsBlank val="1"/>
@@ -2182,7 +2182,7 @@
           <a:p>
             <a:fld id="{C1255C68-584F-174D-BB81-51BF91708794}" type="datetimeFigureOut">
               <a:rPr lang="en-US" smtClean="0"/>
-              <a:t>1/29/26</a:t>
+              <a:t>3/13/26</a:t>
             </a:fld>
             <a:endParaRPr lang="en-US"/>
           </a:p>
@@ -2359,7 +2359,7 @@
           <a:p>
             <a:fld id="{A1EDAAC4-819D-C544-9EA1-C73624CFD70B}" type="datetimeFigureOut">
               <a:rPr lang="en-US" smtClean="0"/>
-              <a:t>1/29/26</a:t>
+              <a:t>3/13/26</a:t>
             </a:fld>
             <a:endParaRPr lang="en-US"/>
           </a:p>
@@ -11480,12 +11480,12 @@
             <p:nvPr userDrawn="1"/>
           </p:nvPicPr>
           <p:blipFill>
-            <a:blip r:embed="rId2">
+            <a:blip>
               <a:lum bright="100000"/>
               <a:alphaModFix amt="80000"/>
               <a:extLst>
                 <a:ext uri="{96DAC541-7B7A-43D3-8B79-37D633B846F1}">
-                  <asvg:svgBlip xmlns:asvg="http://schemas.microsoft.com/office/drawing/2016/SVG/main" r:embed="rId3"/>
+                  <asvg:svgBlip xmlns:asvg="http://schemas.microsoft.com/office/drawing/2016/SVG/main" r:embed="rId2"/>
                 </a:ext>
               </a:extLst>
             </a:blip>
@@ -11597,12 +11597,12 @@
             <p:nvPr userDrawn="1"/>
           </p:nvPicPr>
           <p:blipFill>
-            <a:blip r:embed="rId4">
+            <a:blip>
               <a:lum bright="100000"/>
               <a:alphaModFix amt="80000"/>
               <a:extLst>
                 <a:ext uri="{96DAC541-7B7A-43D3-8B79-37D633B846F1}">
-                  <asvg:svgBlip xmlns:asvg="http://schemas.microsoft.com/office/drawing/2016/SVG/main" r:embed="rId5"/>
+                  <asvg:svgBlip xmlns:asvg="http://schemas.microsoft.com/office/drawing/2016/SVG/main" r:embed="rId3"/>
                 </a:ext>
               </a:extLst>
             </a:blip>
@@ -11714,12 +11714,12 @@
             <p:nvPr userDrawn="1"/>
           </p:nvPicPr>
           <p:blipFill>
-            <a:blip r:embed="rId6">
+            <a:blip>
               <a:lum bright="100000"/>
               <a:alphaModFix amt="80000"/>
               <a:extLst>
                 <a:ext uri="{96DAC541-7B7A-43D3-8B79-37D633B846F1}">
-                  <asvg:svgBlip xmlns:asvg="http://schemas.microsoft.com/office/drawing/2016/SVG/main" r:embed="rId7"/>
+                  <asvg:svgBlip xmlns:asvg="http://schemas.microsoft.com/office/drawing/2016/SVG/main" r:embed="rId4"/>
                 </a:ext>
               </a:extLst>
             </a:blip>
@@ -11820,12 +11820,12 @@
             <p:nvPr userDrawn="1"/>
           </p:nvPicPr>
           <p:blipFill>
-            <a:blip r:embed="rId8">
+            <a:blip>
               <a:lum bright="100000"/>
               <a:alphaModFix amt="80000"/>
               <a:extLst>
                 <a:ext uri="{96DAC541-7B7A-43D3-8B79-37D633B846F1}">
-                  <asvg:svgBlip xmlns:asvg="http://schemas.microsoft.com/office/drawing/2016/SVG/main" r:embed="rId9"/>
+                  <asvg:svgBlip xmlns:asvg="http://schemas.microsoft.com/office/drawing/2016/SVG/main" r:embed="rId5"/>
                 </a:ext>
               </a:extLst>
             </a:blip>
@@ -11948,12 +11948,12 @@
             <p:nvPr userDrawn="1"/>
           </p:nvPicPr>
           <p:blipFill>
-            <a:blip r:embed="rId10">
+            <a:blip>
               <a:lum bright="100000"/>
               <a:alphaModFix amt="80000"/>
               <a:extLst>
                 <a:ext uri="{96DAC541-7B7A-43D3-8B79-37D633B846F1}">
-                  <asvg:svgBlip xmlns:asvg="http://schemas.microsoft.com/office/drawing/2016/SVG/main" r:embed="rId11"/>
+                  <asvg:svgBlip xmlns:asvg="http://schemas.microsoft.com/office/drawing/2016/SVG/main" r:embed="rId6"/>
                 </a:ext>
               </a:extLst>
             </a:blip>
@@ -12054,12 +12054,12 @@
             <p:nvPr userDrawn="1"/>
           </p:nvPicPr>
           <p:blipFill>
-            <a:blip r:embed="rId12">
+            <a:blip>
               <a:lum bright="100000"/>
               <a:alphaModFix amt="80000"/>
               <a:extLst>
                 <a:ext uri="{96DAC541-7B7A-43D3-8B79-37D633B846F1}">
-                  <asvg:svgBlip xmlns:asvg="http://schemas.microsoft.com/office/drawing/2016/SVG/main" r:embed="rId13"/>
+                  <asvg:svgBlip xmlns:asvg="http://schemas.microsoft.com/office/drawing/2016/SVG/main" r:embed="rId7"/>
                 </a:ext>
               </a:extLst>
             </a:blip>
@@ -22756,7 +22756,6 @@
               <a:rPr lang="en-US" dirty="0"/>
               <a:t>Software Quality report on Opendemo</a:t>
             </a:r>
-            <a:endParaRPr lang="en-US" dirty="0"/>
           </a:p>
         </p:txBody>
       </p:sp>
@@ -31629,10 +31628,10 @@
               <p:nvPr/>
             </p:nvPicPr>
             <p:blipFill>
-              <a:blip r:embed="rId2">
+              <a:blip>
                 <a:extLst>
                   <a:ext uri="{96DAC541-7B7A-43D3-8B79-37D633B846F1}">
-                    <asvg:svgBlip xmlns:asvg="http://schemas.microsoft.com/office/drawing/2016/SVG/main" r:embed="rId3"/>
+                    <asvg:svgBlip xmlns:asvg="http://schemas.microsoft.com/office/drawing/2016/SVG/main" r:embed="rId2"/>
                   </a:ext>
                 </a:extLst>
               </a:blip>
@@ -31970,10 +31969,10 @@
               <p:nvPr/>
             </p:nvPicPr>
             <p:blipFill>
-              <a:blip r:embed="rId4">
+              <a:blip>
                 <a:extLst>
                   <a:ext uri="{96DAC541-7B7A-43D3-8B79-37D633B846F1}">
-                    <asvg:svgBlip xmlns:asvg="http://schemas.microsoft.com/office/drawing/2016/SVG/main" r:embed="rId5"/>
+                    <asvg:svgBlip xmlns:asvg="http://schemas.microsoft.com/office/drawing/2016/SVG/main" r:embed="rId3"/>
                   </a:ext>
                 </a:extLst>
               </a:blip>
@@ -32622,7 +32621,7 @@
         </p:nvGraphicFramePr>
         <p:xfrm>
           <a:off x="937766" y="1466791"/>
-          <a:ext cx="10316468" cy="17341920"/>
+          <a:ext cx="10316468" cy="4540320"/>
         </p:xfrm>
         <a:graphic>
           <a:graphicData uri="http://schemas.openxmlformats.org/drawingml/2006/table">
@@ -39621,55 +39620,6 @@
               <a:rPr lang="en-US"/>
               <a:t>Systems with the most technical debt</a:t>
             </a:r>
-          </a:p>
-        </p:txBody>
-      </p:sp>
-      <p:sp>
-        <p:nvSpPr>
-          <p:cNvPr id="6" name="TextBox 5">
-            <a:extLst>
-              <a:ext uri="{FF2B5EF4-FFF2-40B4-BE49-F238E27FC236}">
-                <a16:creationId xmlns:a16="http://schemas.microsoft.com/office/drawing/2014/main" id="{777043DA-728E-44E3-4252-8FC6DEA66304}"/>
-              </a:ext>
-            </a:extLst>
-          </p:cNvPr>
-          <p:cNvSpPr txBox="1"/>
-          <p:nvPr/>
-        </p:nvSpPr>
-        <p:spPr>
-          <a:xfrm>
-            <a:off x="10058400" y="-373182"/>
-            <a:ext cx="3177686" cy="355162"/>
-          </a:xfrm>
-          <a:prstGeom prst="rect">
-            <a:avLst/>
-          </a:prstGeom>
-          <a:noFill/>
-        </p:spPr>
-        <p:txBody>
-          <a:bodyPr wrap="none" lIns="90000" rtlCol="0" anchor="t">
-            <a:spAutoFit/>
-          </a:bodyPr>
-          <a:lstStyle/>
-          <a:p>
-            <a:pPr algn="l">
-              <a:lnSpc>
-                <a:spcPct val="113000"/>
-              </a:lnSpc>
-            </a:pPr>
-            <a:r>
-              <a:rPr lang="en-US" sz="1600" dirty="0" err="1">
-                <a:solidFill>
-                  <a:schemeClr val="tx2"/>
-                </a:solidFill>
-              </a:rPr>
-              <a:t>TECHNICAL_DEBT_SYSTEMS_CHART</a:t>
-            </a:r>
-            <a:endParaRPr lang="en-US" sz="1600" dirty="0">
-              <a:solidFill>
-                <a:schemeClr val="tx2"/>
-              </a:solidFill>
-            </a:endParaRPr>
           </a:p>
         </p:txBody>
       </p:sp>
@@ -41305,26 +41255,6 @@
 </file>
 
 <file path=customXml/item1.xml><?xml version="1.0" encoding="utf-8"?>
-<p:properties xmlns:p="http://schemas.microsoft.com/office/2006/metadata/properties" xmlns:xsi="http://www.w3.org/2001/XMLSchema-instance" xmlns:pc="http://schemas.microsoft.com/office/infopath/2007/PartnerControls">
-  <documentManagement>
-    <lcf76f155ced4ddcb4097134ff3c332f xmlns="fa937df2-abe2-4d38-b5f4-c228acba3827">
-      <Terms xmlns="http://schemas.microsoft.com/office/infopath/2007/PartnerControls"/>
-    </lcf76f155ced4ddcb4097134ff3c332f>
-    <TaxCatchAll xmlns="bc8ba18a-4a58-4ad2-bfc0-6516af8e7dc2" xsi:nil="true"/>
-  </documentManagement>
-</p:properties>
-</file>
-
-<file path=customXml/item2.xml><?xml version="1.0" encoding="utf-8"?>
-<?mso-contentType ?>
-<FormTemplates xmlns="http://schemas.microsoft.com/sharepoint/v3/contenttype/forms">
-  <Display>DocumentLibraryForm</Display>
-  <Edit>DocumentLibraryForm</Edit>
-  <New>DocumentLibraryForm</New>
-</FormTemplates>
-</file>
-
-<file path=customXml/item3.xml><?xml version="1.0" encoding="utf-8"?>
 <ct:contentTypeSchema xmlns:ct="http://schemas.microsoft.com/office/2006/metadata/contentType" xmlns:ma="http://schemas.microsoft.com/office/2006/metadata/properties/metaAttributes" ct:_="" ma:_="" ma:contentTypeName="Document" ma:contentTypeID="0x010100398B4EB28540854BB4092730D7F67224" ma:contentTypeVersion="13" ma:contentTypeDescription="Create a new document." ma:contentTypeScope="" ma:versionID="07d6997c7358ecc3b6f0d78039f1ac55">
   <xsd:schema xmlns:xsd="http://www.w3.org/2001/XMLSchema" xmlns:xs="http://www.w3.org/2001/XMLSchema" xmlns:p="http://schemas.microsoft.com/office/2006/metadata/properties" xmlns:ns2="fa937df2-abe2-4d38-b5f4-c228acba3827" xmlns:ns3="bc8ba18a-4a58-4ad2-bfc0-6516af8e7dc2" targetNamespace="http://schemas.microsoft.com/office/2006/metadata/properties" ma:root="true" ma:fieldsID="a7d20d2c9a349b6838acf4b79389f2fd" ns2:_="" ns3:_="">
     <xsd:import namespace="fa937df2-abe2-4d38-b5f4-c228acba3827"/>
@@ -41547,32 +41477,27 @@
 </ct:contentTypeSchema>
 </file>
 
-<file path=customXml/itemProps1.xml><?xml version="1.0" encoding="utf-8"?>
-<ds:datastoreItem xmlns:ds="http://schemas.openxmlformats.org/officeDocument/2006/customXml" ds:itemID="{4B629362-CF15-4610-8FAC-A8E699942233}">
-  <ds:schemaRefs>
-    <ds:schemaRef ds:uri="http://schemas.microsoft.com/office/2006/documentManagement/types"/>
-    <ds:schemaRef ds:uri="http://purl.org/dc/elements/1.1/"/>
-    <ds:schemaRef ds:uri="bc8ba18a-4a58-4ad2-bfc0-6516af8e7dc2"/>
-    <ds:schemaRef ds:uri="http://purl.org/dc/terms/"/>
-    <ds:schemaRef ds:uri="http://www.w3.org/XML/1998/namespace"/>
-    <ds:schemaRef ds:uri="http://schemas.microsoft.com/office/2006/metadata/properties"/>
-    <ds:schemaRef ds:uri="http://schemas.microsoft.com/office/infopath/2007/PartnerControls"/>
-    <ds:schemaRef ds:uri="http://schemas.openxmlformats.org/package/2006/metadata/core-properties"/>
-    <ds:schemaRef ds:uri="fa937df2-abe2-4d38-b5f4-c228acba3827"/>
-    <ds:schemaRef ds:uri="http://purl.org/dc/dcmitype/"/>
-  </ds:schemaRefs>
-</ds:datastoreItem>
+<file path=customXml/item2.xml><?xml version="1.0" encoding="utf-8"?>
+<?mso-contentType ?>
+<FormTemplates xmlns="http://schemas.microsoft.com/sharepoint/v3/contenttype/forms">
+  <Display>DocumentLibraryForm</Display>
+  <Edit>DocumentLibraryForm</Edit>
+  <New>DocumentLibraryForm</New>
+</FormTemplates>
 </file>
 
-<file path=customXml/itemProps2.xml><?xml version="1.0" encoding="utf-8"?>
-<ds:datastoreItem xmlns:ds="http://schemas.openxmlformats.org/officeDocument/2006/customXml" ds:itemID="{570928F0-D7CA-4732-B7F3-1F945720D0AA}">
-  <ds:schemaRefs>
-    <ds:schemaRef ds:uri="http://schemas.microsoft.com/sharepoint/v3/contenttype/forms"/>
-  </ds:schemaRefs>
-</ds:datastoreItem>
+<file path=customXml/item3.xml><?xml version="1.0" encoding="utf-8"?>
+<p:properties xmlns:p="http://schemas.microsoft.com/office/2006/metadata/properties" xmlns:xsi="http://www.w3.org/2001/XMLSchema-instance" xmlns:pc="http://schemas.microsoft.com/office/infopath/2007/PartnerControls">
+  <documentManagement>
+    <lcf76f155ced4ddcb4097134ff3c332f xmlns="fa937df2-abe2-4d38-b5f4-c228acba3827">
+      <Terms xmlns="http://schemas.microsoft.com/office/infopath/2007/PartnerControls"/>
+    </lcf76f155ced4ddcb4097134ff3c332f>
+    <TaxCatchAll xmlns="bc8ba18a-4a58-4ad2-bfc0-6516af8e7dc2" xsi:nil="true"/>
+  </documentManagement>
+</p:properties>
 </file>
 
-<file path=customXml/itemProps3.xml><?xml version="1.0" encoding="utf-8"?>
+<file path=customXml/itemProps1.xml><?xml version="1.0" encoding="utf-8"?>
 <ds:datastoreItem xmlns:ds="http://schemas.openxmlformats.org/officeDocument/2006/customXml" ds:itemID="{06E6923A-C221-4753-B75B-BA213EEB7564}">
   <ds:schemaRefs>
     <ds:schemaRef ds:uri="bc8ba18a-4a58-4ad2-bfc0-6516af8e7dc2"/>
@@ -41589,4 +41514,29 @@
     <ds:schemaRef ds:uri="http://www.w3.org/2001/XMLSchema"/>
   </ds:schemaRefs>
 </ds:datastoreItem>
+</file>
+
+<file path=customXml/itemProps2.xml><?xml version="1.0" encoding="utf-8"?>
+<ds:datastoreItem xmlns:ds="http://schemas.openxmlformats.org/officeDocument/2006/customXml" ds:itemID="{570928F0-D7CA-4732-B7F3-1F945720D0AA}">
+  <ds:schemaRefs>
+    <ds:schemaRef ds:uri="http://schemas.microsoft.com/sharepoint/v3/contenttype/forms"/>
+  </ds:schemaRefs>
+</ds:datastoreItem>
+</file>
+
+<file path=customXml/itemProps3.xml><?xml version="1.0" encoding="utf-8"?>
+<ds:datastoreItem xmlns:ds="http://schemas.openxmlformats.org/officeDocument/2006/customXml" ds:itemID="{4B629362-CF15-4610-8FAC-A8E699942233}">
+  <ds:schemaRefs>
+    <ds:schemaRef ds:uri="http://schemas.microsoft.com/office/2006/documentManagement/types"/>
+    <ds:schemaRef ds:uri="http://purl.org/dc/elements/1.1/"/>
+    <ds:schemaRef ds:uri="bc8ba18a-4a58-4ad2-bfc0-6516af8e7dc2"/>
+    <ds:schemaRef ds:uri="http://purl.org/dc/terms/"/>
+    <ds:schemaRef ds:uri="http://www.w3.org/XML/1998/namespace"/>
+    <ds:schemaRef ds:uri="http://schemas.microsoft.com/office/2006/metadata/properties"/>
+    <ds:schemaRef ds:uri="http://schemas.microsoft.com/office/infopath/2007/PartnerControls"/>
+    <ds:schemaRef ds:uri="http://schemas.openxmlformats.org/package/2006/metadata/core-properties"/>
+    <ds:schemaRef ds:uri="fa937df2-abe2-4d38-b5f4-c228acba3827"/>
+    <ds:schemaRef ds:uri="http://purl.org/dc/dcmitype/"/>
+  </ds:schemaRefs>
+</ds:datastoreItem>
 </file>
</xml_diff>